<commit_message>
Record that shortening texts does not shrink the presentation
Four upload attempts for Wiedmann & Winz failed, so the note now says
what actually happens: cutting two potenziale, two painkiller points and
tightening every bullet moved the file from 18.064 to 18.018 bytes. The
compressed size comes from the XML structure of the six slides plus about
2,8 KB of zip bookkeeping, not from the text, and repacking with every
deflate strategy gained nothing. About 18 KB is the floor for the
mandated layout, so texts should no longer be cut for size.

The Wiedmann & Winz content is restored to the fuller wording and the
service account idea is written down as the open decision it is.

Co-Authored-By: Claude Opus 5 <noreply@anthropic.com>
Claude-Session: https://claude.ai/code/session_012oWyUSWf5ZiJJNpmrjt8g8
</commit_message>
<xml_diff>
--- a/.claude/skills/impact-ladder-pdf/output/2026-09-03-impact-ladder-wiedmann-winz.pptx
+++ b/.claude/skills/impact-ladder-pdf/output/2026-09-03-impact-ladder-wiedmann-winz.pptx
@@ -1223,7 +1223,7 @@
                 </a:solidFill>
                 <a:latin typeface="DM Sans"/>
               </a:rPr>
-              <a:t>Jede Abteilung bestellt anders</a:t>
+              <a:t>Jede Abteilung bestellt nach eigenem Muster</a:t>
             </a:r>
           </a:p>
           <a:p>
@@ -1245,7 +1245,7 @@
                 </a:solidFill>
                 <a:latin typeface="DM Sans"/>
               </a:rPr>
-              <a:t>Werkstatt, Büro und IT arbeiten mit gewachsenen Abläufen.</a:t>
+              <a:t>Werkstatt, Büro und IT arbeiten mit historisch gewachsenen Abläufen.</a:t>
             </a:r>
           </a:p>
         </p:txBody>
@@ -1382,7 +1382,7 @@
                 </a:solidFill>
                 <a:latin typeface="DM Sans"/>
               </a:rPr>
-              <a:t>Preisvergleich von Hand bei 2 bis 4 Anbietern</a:t>
+              <a:t>Preisvergleich läuft von Hand bei 2 bis 4 Anbietern</a:t>
             </a:r>
           </a:p>
           <a:p>
@@ -1404,7 +1404,7 @@
                 </a:solidFill>
                 <a:latin typeface="DM Sans"/>
               </a:rPr>
-              <a:t>Angebote werden je Bestellung einzeln gesucht und verglichen.</a:t>
+              <a:t>Für jede Bestellung werden Angebote einzeln gesucht und verglichen.</a:t>
             </a:r>
           </a:p>
         </p:txBody>
@@ -1541,7 +1541,7 @@
                 </a:solidFill>
                 <a:latin typeface="DM Sans"/>
               </a:rPr>
-              <a:t>Preise je Lieferant sehr unterschiedlich</a:t>
+              <a:t>Gleiche Teile kosten je Lieferant sehr unterschiedlich</a:t>
             </a:r>
           </a:p>
           <a:p>
@@ -1563,7 +1563,7 @@
                 </a:solidFill>
                 <a:latin typeface="DM Sans"/>
               </a:rPr>
-              <a:t>Beispiel: 450 Euro für ein Werkzeug, anderswo 225 Euro.</a:t>
+              <a:t>Beispiel aus dem Gespräch: 450 Euro für ein Werkzeug, anderswo 225 Euro.</a:t>
             </a:r>
           </a:p>
         </p:txBody>
@@ -1700,7 +1700,7 @@
                 </a:solidFill>
                 <a:latin typeface="DM Sans"/>
               </a:rPr>
-              <a:t>Keine Übersicht über die Ausgaben</a:t>
+              <a:t>Keine Übersicht über die Gesamtausgaben</a:t>
             </a:r>
           </a:p>
           <a:p>
@@ -1722,7 +1722,7 @@
                 </a:solidFill>
                 <a:latin typeface="DM Sans"/>
               </a:rPr>
-              <a:t>Ausgaben nach Lieferant und Warengruppe sind nicht auswertbar.</a:t>
+              <a:t>Ausgaben nach Lieferant und Warengruppe sind heute nicht auswertbar.</a:t>
             </a:r>
           </a:p>
         </p:txBody>
@@ -1966,7 +1966,7 @@
                 </a:solidFill>
                 <a:latin typeface="DM Sans"/>
               </a:rPr>
-              <a:t>•  Eine Anlaufstelle für Werkstatt, Büro und IT (Intake Agent)</a:t>
+              <a:t>•  Eine Anlaufstelle für alle Abteilungen, für Werkstatt, Büro und IT (Intake Agent)</a:t>
             </a:r>
           </a:p>
           <a:p>
@@ -1988,7 +1988,7 @@
                 </a:solidFill>
                 <a:latin typeface="DM Sans"/>
               </a:rPr>
-              <a:t>•  Integrierte Punch-out-Kataloge für die bestehenden Lieferanten</a:t>
+              <a:t>•  Integrierte Punch-out-Kataloge für die bestehenden und langjährigen Lieferanten</a:t>
             </a:r>
           </a:p>
           <a:p>
@@ -2010,7 +2010,7 @@
                 </a:solidFill>
                 <a:latin typeface="DM Sans"/>
               </a:rPr>
-              <a:t>•  Preisvergleich der angebundenen Lieferanten im System (Comparison Agent)</a:t>
+              <a:t>•  Preisvergleich zwischen den angebundenen Lieferanten direkt im System (Comparison Agent)</a:t>
             </a:r>
           </a:p>
           <a:p>
@@ -2032,7 +2032,7 @@
                 </a:solidFill>
                 <a:latin typeface="DM Sans"/>
               </a:rPr>
-              <a:t>•  Kostenstelle und Sachkonto schon bei der Anforderung (Category Agent)</a:t>
+              <a:t>•  Kostenstelle, Sachkonto und Lieferadresse werden bereits bei der Anforderung hinterlegt (Category Agent)</a:t>
             </a:r>
           </a:p>
           <a:p>
@@ -2054,7 +2054,7 @@
                 </a:solidFill>
                 <a:latin typeface="DM Sans"/>
               </a:rPr>
-              <a:t>•  Freigaben nach Wert, Warengruppe und Kostenstelle (Approval Agent)</a:t>
+              <a:t>•  Strukturierte Freigaben nach Wert, Warengruppe und Kostenstelle (Approval Agent)</a:t>
             </a:r>
           </a:p>
         </p:txBody>
@@ -2191,7 +2191,7 @@
                 </a:solidFill>
                 <a:latin typeface="DM Sans"/>
               </a:rPr>
-              <a:t>•  Freigabe direkt aus MS Teams heraus (MS Teams Agent)</a:t>
+              <a:t>•  Freigabe direkt aus MS Teams heraus, ohne Systemwechsel (MS Teams Agent)</a:t>
             </a:r>
           </a:p>
           <a:p>
@@ -2213,7 +2213,7 @@
                 </a:solidFill>
                 <a:latin typeface="DM Sans"/>
               </a:rPr>
-              <a:t>•  Wareneingang mit Lieferschein und Schadensmeldung dokumentieren</a:t>
+              <a:t>•  Wareneingang dokumentieren, inklusive Lieferschein und Schadensmeldung</a:t>
             </a:r>
           </a:p>
           <a:p>
@@ -2235,7 +2235,7 @@
                 </a:solidFill>
                 <a:latin typeface="DM Sans"/>
               </a:rPr>
-              <a:t>•  Bestelldaten an d.velop D3, Rechnungen laufen dunkel durch (Invoice Agent)</a:t>
+              <a:t>•  Übergabe der Bestelldaten an d.velop D3, Rechnungen können dunkel durchlaufen (Invoice Agent)</a:t>
             </a:r>
           </a:p>
           <a:p>
@@ -2257,7 +2257,29 @@
                 </a:solidFill>
                 <a:latin typeface="DM Sans"/>
               </a:rPr>
-              <a:t>•  Ausgaben nach Lieferant und Warengruppe auswerten (Analytics Agent)</a:t>
+              <a:t>•  Auswertung der Ausgaben nach Lieferant, Warengruppe und Zeitraum (Analytics Agent)</a:t>
+            </a:r>
+          </a:p>
+          <a:p>
+            <a:pPr>
+              <a:lnSpc>
+                <a:spcPct val="130000"/>
+              </a:lnSpc>
+              <a:spcBef>
+                <a:spcPts val="0"/>
+              </a:spcBef>
+              <a:spcAft>
+                <a:spcPts val="900"/>
+              </a:spcAft>
+            </a:pPr>
+            <a:r>
+              <a:rPr sz="1300" b="0">
+                <a:solidFill>
+                  <a:srgbClr val="204540"/>
+                </a:solidFill>
+                <a:latin typeface="DM Sans"/>
+              </a:rPr>
+              <a:t>•  Leitplanken im System halten Bestellungen im freigegebenen Rahmen (Compliance Agent)</a:t>
             </a:r>
           </a:p>
         </p:txBody>
@@ -2601,7 +2623,7 @@
                 </a:solidFill>
                 <a:latin typeface="DM Sans"/>
               </a:rPr>
-              <a:t>•  Bedarfe werden direkt im System angefordert (Intake Agent).</a:t>
+              <a:t>•  Bedarfe werden direkt im System angefordert, die Mail ins Sekretariat entfällt (Intake Agent).</a:t>
             </a:r>
           </a:p>
           <a:p>
@@ -2723,7 +2745,7 @@
                 </a:solidFill>
                 <a:latin typeface="DM Sans"/>
               </a:rPr>
-              <a:t>Der Weg vom Bedarf zur Bestellung ist überall derselbe.</a:t>
+              <a:t>Der Weg vom Bedarf zur Bestellung ist in allen Abteilungen derselbe und bleibt kurz.</a:t>
             </a:r>
           </a:p>
         </p:txBody>
@@ -2960,7 +2982,7 @@
                 </a:solidFill>
                 <a:latin typeface="DM Sans"/>
               </a:rPr>
-              <a:t>•  Der Preisvergleich der angebundenen Lieferanten passiert im System (Comparison Agent).</a:t>
+              <a:t>•  Der Preisvergleich zwischen den angebundenen Lieferanten passiert im System (Comparison Agent).</a:t>
             </a:r>
           </a:p>
           <a:p>
@@ -2982,7 +3004,7 @@
                 </a:solidFill>
                 <a:latin typeface="DM Sans"/>
               </a:rPr>
-              <a:t>•  Freigaben laufen regelbasiert, die Bestellung löst danach aus (Approval Agent).</a:t>
+              <a:t>•  Freigaben laufen regelbasiert, die Bestellung löst danach automatisch aus (Approval Agent).</a:t>
             </a:r>
           </a:p>
         </p:txBody>
@@ -3082,7 +3104,7 @@
                 </a:solidFill>
                 <a:latin typeface="DM Sans"/>
               </a:rPr>
-              <a:t>Suchen, Vergleichen und Bestellen von Hand entfällt für die meisten Bestellungen.</a:t>
+              <a:t>Suchen, Vergleichen und Bestellen von Hand entfällt für den Großteil der Bestellungen.</a:t>
             </a:r>
           </a:p>
         </p:txBody>
@@ -3426,7 +3448,7 @@
                 </a:solidFill>
                 <a:latin typeface="DM Sans"/>
               </a:rPr>
-              <a:t>•  Kostenstelle und Sachkonto stehen schon bei der Anforderung fest (Accounting Agent).</a:t>
+              <a:t>•  Kostenstelle, Sachkonto und Lieferadresse stehen schon bei der Anforderung fest (Accounting Agent).</a:t>
             </a:r>
           </a:p>
           <a:p>
@@ -3448,7 +3470,7 @@
                 </a:solidFill>
                 <a:latin typeface="DM Sans"/>
               </a:rPr>
-              <a:t>•  Bestelldaten gehen an d.velop D3, Rechnungen mit Bestellbezug laufen durch (Invoice Agent).</a:t>
+              <a:t>•  Bestelldaten gehen an d.velop D3, Rechnungen mit Bestellbezug laufen ohne Eingriff durch (Invoice Agent).</a:t>
             </a:r>
           </a:p>
         </p:txBody>
@@ -3785,7 +3807,7 @@
                 </a:solidFill>
                 <a:latin typeface="DM Sans"/>
               </a:rPr>
-              <a:t>•  Ausgaben nach Lieferant, Warengruppe und Zeitraum sind auswertbar (Analytics Agent).</a:t>
+              <a:t>•  Ausgaben nach Lieferant, Warengruppe und Zeitraum sind jederzeit auswertbar (Analytics Agent).</a:t>
             </a:r>
           </a:p>
           <a:p>
@@ -3807,7 +3829,7 @@
                 </a:solidFill>
                 <a:latin typeface="DM Sans"/>
               </a:rPr>
-              <a:t>•  Leitplanken halten Bestellungen im freigegebenen Rahmen (Compliance Agent).</a:t>
+              <a:t>•  Leitplanken im System halten Bestellungen im freigegebenen Rahmen (Compliance Agent).</a:t>
             </a:r>
           </a:p>
         </p:txBody>
@@ -3907,7 +3929,7 @@
                 </a:solidFill>
                 <a:latin typeface="DM Sans"/>
               </a:rPr>
-              <a:t>Die Zahlen für den Business Case entstehen im laufenden Betrieb.</a:t>
+              <a:t>Die Zahlen für den Business Case entstehen im laufenden Betrieb, nicht durch Nachfragen.</a:t>
             </a:r>
           </a:p>
         </p:txBody>
@@ -4149,7 +4171,7 @@
                 </a:solidFill>
                 <a:latin typeface="Frank Ruhl Libre"/>
               </a:rPr>
-              <a:t>Wiedmann &amp; Winz erhält einen einheitlichen Bestellweg für alle Abteilungen, der Preisvergleich läuft im System statt von Hand, und die Ausgaben werden auswertbar.</a:t>
+              <a:t>Wiedmann &amp; Winz erhält einen einheitlichen Bestellweg für alle Abteilungen, der Preisvergleich läuft im System statt von Hand, und die Ausgaben werden nach Lieferant und Warengruppe auswertbar.</a:t>
             </a:r>
           </a:p>
         </p:txBody>
@@ -4239,7 +4261,7 @@
                 </a:solidFill>
                 <a:latin typeface="DM Sans"/>
               </a:rPr>
-              <a:t>•  ca. 10 Nutzer würden im System arbeiten (belegt)</a:t>
+              <a:t>•  ca. 10 Nutzer würden im System arbeiten, Schätzung aus dem Gespräch (belegt)</a:t>
             </a:r>
           </a:p>
           <a:p>
@@ -4261,7 +4283,7 @@
                 </a:solidFill>
                 <a:latin typeface="DM Sans"/>
               </a:rPr>
-              <a:t>•  Preisvergleich heute bei 2 bis 4 Anbietern (belegt)</a:t>
+              <a:t>•  Preisvergleich heute bei 2 bis 4 Anbietern pro Bestellung (belegt)</a:t>
             </a:r>
           </a:p>
           <a:p>
@@ -4283,7 +4305,7 @@
                 </a:solidFill>
                 <a:latin typeface="DM Sans"/>
               </a:rPr>
-              <a:t>•  Vorgänge mit 4.000 bis 10.000 Euro genannt (belegt)</a:t>
+              <a:t>•  Einzelne Vorgänge mit 4.000 bis 10.000 Euro Einkaufsvolumen genannt (belegt)</a:t>
             </a:r>
           </a:p>
           <a:p>
@@ -4305,7 +4327,7 @@
                 </a:solidFill>
                 <a:latin typeface="DM Sans"/>
               </a:rPr>
-              <a:t>•  Einsparung durch Bündelung und Preisvergleich (annahme)</a:t>
+              <a:t>•  Einsparung durch Bündelung und systemgestützten Preisvergleich (annahme)</a:t>
             </a:r>
           </a:p>
         </p:txBody>
@@ -4395,7 +4417,7 @@
                 </a:solidFill>
                 <a:latin typeface="DM Sans"/>
               </a:rPr>
-              <a:t>•  Bestellungen pro Monat und Einkaufsvolumen sind noch offen.</a:t>
+              <a:t>•  Anzahl der Bestellungen pro Monat und indirektes Einkaufsvolumen sind noch offen.</a:t>
             </a:r>
           </a:p>
           <a:p>
@@ -4417,7 +4439,7 @@
                 </a:solidFill>
                 <a:latin typeface="DM Sans"/>
               </a:rPr>
-              <a:t>•  Das angepasste Angebot ohne ERP-Schnittstelle steht aus.</a:t>
+              <a:t>•  Das angepasste Angebot ohne ERP-Schnittstelle steht noch aus.</a:t>
             </a:r>
           </a:p>
           <a:p>
@@ -4439,7 +4461,7 @@
                 </a:solidFill>
                 <a:latin typeface="DM Sans"/>
               </a:rPr>
-              <a:t>•  Ein freier Preisvergleich im Internet ist heute nicht möglich.</a:t>
+              <a:t>•  Ein freier Preisvergleich im offenen Internet ist heute nicht möglich.</a:t>
             </a:r>
           </a:p>
         </p:txBody>
@@ -4532,7 +4554,7 @@
                 </a:solidFill>
                 <a:latin typeface="DM Sans"/>
               </a:rPr>
-              <a:t>Im Testzugang sehen Sie den Ablauf mit Ihren eigenen Bedarfen, im Folgetermin am 24. September ordnen wir die Zahlen ein.</a:t>
+              <a:t>Im Testzugang sehen Sie den Ablauf mit Ihren eigenen Bedarfen, im Folgetermin am 24. September ordnen wir die Zahlen gemeinsam ein.</a:t>
             </a:r>
           </a:p>
         </p:txBody>

</xml_diff>